<commit_message>
Finalize solution-focused pitch and submission readiness
</commit_message>
<xml_diff>
--- a/presentation/pitch/output/lado-pitch.pptx
+++ b/presentation/pitch/output/lado-pitch.pptx
@@ -509,7 +509,7 @@
           <a:p>
             <a:r>
               <a:rPr lang="en-US" dirty="0"/>
-              <a:t>Камера уже фиксирует кассовую операцию. Но длинная запись не говорит проверяющему, с какого момента начинать разбор и на каком основании. Lado приводит специалиста к конкретному эпизоду и сохраняет связь между исходным временем, наблюдаемыми действиями, правилом и решением человека.
+              <a:t>Lado принимает видеозапись кассовой операции и возвращает конкретный эпизод проверки: исходный таймкод, наблюдения, кадры-доказательства и правило. Специалист открывает запись сразу в нужном месте, видит основание и отдельно фиксирует решение.
 Источники слайда: contracts/product.json; README.md; identity/logo/lado-logo-on-stage.svg. CGI provenance: assets/imagegen/redesign-prompts.md.</a:t>
             </a:r>
             <a:endParaRPr lang="en-US" dirty="0"/>
@@ -776,7 +776,7 @@
           <a:p>
             <a:r>
               <a:rPr lang="en-US" dirty="0"/>
-              <a:t>Главная техническая задача находится во времени. На каждом интервале система связывает участников и кассовые предметы, различает состояние наличных и действие, а затем сохраняет порядок событий. Передача, пересчёт и работа с той же пачкой имеют смысл только вместе с ролями, видимостью и общим временным окном. Правило получает эту последовательность, а не один изолированный кадр.
+              <a:t>Lado связывает участников и кассовые предметы во времени, различает состояние наличных и действие, а затем сохраняет порядок событий. Qwen анализирует окна до тридцати двух кадров, а треки и исходные таймкоды связывают передачу, пересчёт и работу с той же пачкой. Правило получает эту последовательность вместе с ролями, обзором и временным окном.
 Источники слайда: README.md, sections “Действия во времени” and “Факты и правила”; backend/navidu/perception/grounding.py; rules/catalog/V-COUNT-ABSENT.yaml.</a:t>
             </a:r>
             <a:endParaRPr lang="en-US" dirty="0"/>
@@ -865,7 +865,7 @@
           <a:p>
             <a:r>
               <a:rPr lang="en-US" dirty="0"/>
-              <a:t>Восприятие строится в три слоя. Специализированный детектор ищет руки, наличные, удостоверения и счётчики. Трекинг связывает людей и предметы между кадрами. Qwen3-VL анализирует последовательность действий, после чего программная проверка сверяет идентификаторы объектов и интервалы. CGI на слайде является концептуальной иллюстрацией предметов, а не кадром из банка или результатом анализа.
+              <a:t>Восприятие строится в три слоя. RF-DETR Nano находит людей и общие объекты. Обученный RT-DETRv2-r18 распознаёт руки, банкноты и счётчик в составном предметном профиле. Qwen3-VL-8B-Instruct анализирует последовательность действий, после чего программная проверка сверяет идентификаторы объектов и интервалы. CGI на слайде является концептуальной иллюстрацией, а не банковским кадром.
 Источники слайда: README.md; backend/navidu/perception/object_detector.py; backend/navidu/perception/qwen.py; backend/navidu/perception/grounding.py. CGI provenance: assets/imagegen/redesign-prompts.md.</a:t>
             </a:r>
             <a:endParaRPr lang="en-US" dirty="0"/>
@@ -1132,8 +1132,8 @@
           <a:p>
             <a:r>
               <a:rPr lang="en-US" dirty="0"/>
-              <a:t>Предлагаю проверить Lado на ваших сценариях. Можно выбрать один процесс контроля, согласовать критерии и источники, затем сопоставить найденные эпизоды с решениями специалистов. Рабочий сервис и HTTP API уже доступны, а репозиторий открывается по приглашению.
-Источники слайда: README.md; working service URL; repository URL supplied by project.</a:t>
+              <a:t>Lado принимает видео через защищённый HTTP API, анализирует его в частном контуре и возвращает проверяемые эпизоды с таймкодом, правилом и кадрами-доказательствами. Рабочий сервис и публичный репозиторий доступны по ссылкам.
+Источники слайда: README.md; working service URL; public repository URL supplied by project.</a:t>
             </a:r>
             <a:endParaRPr lang="en-US" dirty="0"/>
           </a:p>
@@ -1595,25 +1595,25 @@
         <p:spPr>
           <a:xfrm>
             <a:off x="658368" y="1426464"/>
-            <a:ext cx="4617720" cy="1737360"/>
-          </a:xfrm>
-          <a:prstGeom prst="rect">
-            <a:avLst/>
-          </a:prstGeom>
-          <a:noFill/>
-          <a:ln/>
-        </p:spPr>
-        <p:txBody>
-          <a:bodyPr wrap="square" lIns="0" tIns="0" rIns="0" bIns="0" rtlCol="0" anchor="t">
-            <a:normAutofit/>
-          </a:bodyPr>
-          <a:lstStyle/>
-          <a:p>
-            <a:pPr algn="l" indent="0" marL="0">
-              <a:buNone/>
-            </a:pPr>
-            <a:r>
-              <a:rPr lang="en-US" sz="5700" b="1" dirty="0">
+            <a:ext cx="4846320" cy="1737360"/>
+          </a:xfrm>
+          <a:prstGeom prst="rect">
+            <a:avLst/>
+          </a:prstGeom>
+          <a:noFill/>
+          <a:ln/>
+        </p:spPr>
+        <p:txBody>
+          <a:bodyPr wrap="square" lIns="0" tIns="0" rIns="0" bIns="0" rtlCol="0" anchor="t">
+            <a:normAutofit/>
+          </a:bodyPr>
+          <a:lstStyle/>
+          <a:p>
+            <a:pPr algn="l" indent="0" marL="0">
+              <a:buNone/>
+            </a:pPr>
+            <a:r>
+              <a:rPr lang="en-US" sz="5400" b="1" dirty="0">
                 <a:solidFill>
                   <a:srgbClr val="FFFFFF"/>
                 </a:solidFill>
@@ -1621,16 +1621,16 @@
                 <a:ea typeface="Segoe UI" pitchFamily="34" charset="-122"/>
                 <a:cs typeface="Segoe UI" pitchFamily="34" charset="-120"/>
               </a:rPr>
-              <a:t>Всё важное</a:t>
-            </a:r>
-            <a:endParaRPr lang="en-US" sz="5700" dirty="0"/>
-          </a:p>
-          <a:p>
-            <a:pPr algn="l" indent="0" marL="0">
-              <a:buNone/>
-            </a:pPr>
-            <a:r>
-              <a:rPr lang="en-US" sz="5700" b="1" dirty="0">
+              <a:t>Lado находит</a:t>
+            </a:r>
+            <a:endParaRPr lang="en-US" sz="5400" dirty="0"/>
+          </a:p>
+          <a:p>
+            <a:pPr algn="l" indent="0" marL="0">
+              <a:buNone/>
+            </a:pPr>
+            <a:r>
+              <a:rPr lang="en-US" sz="5400" b="1" dirty="0">
                 <a:solidFill>
                   <a:srgbClr val="FFFFFF"/>
                 </a:solidFill>
@@ -1638,9 +1638,9 @@
                 <a:ea typeface="Segoe UI" pitchFamily="34" charset="-122"/>
                 <a:cs typeface="Segoe UI" pitchFamily="34" charset="-120"/>
               </a:rPr>
-              <a:t>на виду.</a:t>
-            </a:r>
-            <a:endParaRPr lang="en-US" sz="5700" dirty="0"/>
+              <a:t>эпизод проверки.</a:t>
+            </a:r>
+            <a:endParaRPr lang="en-US" sz="5400" dirty="0"/>
           </a:p>
         </p:txBody>
       </p:sp>
@@ -1653,7 +1653,7 @@
         <p:spPr>
           <a:xfrm>
             <a:off x="694944" y="3218688"/>
-            <a:ext cx="4526280" cy="804672"/>
+            <a:ext cx="4709160" cy="841248"/>
           </a:xfrm>
           <a:prstGeom prst="rect">
             <a:avLst/>
@@ -1679,7 +1679,7 @@
                 <a:ea typeface="Segoe UI" pitchFamily="34" charset="-122"/>
                 <a:cs typeface="Segoe UI" pitchFamily="34" charset="-120"/>
               </a:rPr>
-              <a:t>Проверка кассовых</a:t>
+              <a:t>Видео → таймкод,</a:t>
             </a:r>
             <a:endParaRPr lang="en-US" sz="2500" dirty="0"/>
           </a:p>
@@ -1696,7 +1696,7 @@
                 <a:ea typeface="Segoe UI" pitchFamily="34" charset="-122"/>
                 <a:cs typeface="Segoe UI" pitchFamily="34" charset="-120"/>
               </a:rPr>
-              <a:t>операций по видео</a:t>
+              <a:t>доказательства и правило</a:t>
             </a:r>
             <a:endParaRPr lang="en-US" sz="2500" dirty="0"/>
           </a:p>
@@ -1711,7 +1711,7 @@
         <p:spPr>
           <a:xfrm>
             <a:off x="694944" y="4187952"/>
-            <a:ext cx="4498848" cy="1133856"/>
+            <a:ext cx="4617720" cy="1133856"/>
           </a:xfrm>
           <a:prstGeom prst="rect">
             <a:avLst/>
@@ -1737,7 +1737,7 @@
                 <a:ea typeface="Segoe UI" pitchFamily="34" charset="-122"/>
                 <a:cs typeface="Segoe UI" pitchFamily="34" charset="-120"/>
               </a:rPr>
-              <a:t>Lado приводит специалиста к моменту, который стоит проверить.</a:t>
+              <a:t>Специалист сразу открывает нужный момент и принимает решение.</a:t>
             </a:r>
             <a:endParaRPr lang="en-US" sz="2300" dirty="0"/>
           </a:p>
@@ -3267,7 +3267,7 @@
                 <a:ea typeface="Segoe UI" pitchFamily="34" charset="-122"/>
                 <a:cs typeface="Segoe UI" pitchFamily="34" charset="-120"/>
               </a:rPr>
-              <a:t>Один кадр показывает состояние.</a:t>
+              <a:t>Qwen анализирует окна до 32 кадров.</a:t>
             </a:r>
             <a:endParaRPr lang="en-US" sz="2300" dirty="0"/>
           </a:p>
@@ -3284,7 +3284,7 @@
                 <a:ea typeface="Segoe UI" pitchFamily="34" charset="-122"/>
                 <a:cs typeface="Segoe UI" pitchFamily="34" charset="-120"/>
               </a:rPr>
-              <a:t>Последовательность показывает действие.</a:t>
+              <a:t>Треки и исходные таймкоды связывают события.</a:t>
             </a:r>
             <a:endParaRPr lang="en-US" sz="2300" dirty="0"/>
           </a:p>
@@ -4442,7 +4442,7 @@
         </p:nvSpPr>
         <p:spPr>
           <a:xfrm>
-            <a:off x="7699248" y="1444752"/>
+            <a:off x="7699248" y="1408176"/>
             <a:ext cx="3840480" cy="512064"/>
           </a:xfrm>
           <a:prstGeom prst="rect">
@@ -4469,7 +4469,7 @@
                 <a:ea typeface="Segoe UI" pitchFamily="34" charset="-122"/>
                 <a:cs typeface="Segoe UI" pitchFamily="34" charset="-120"/>
               </a:rPr>
-              <a:t>Детекторы предметов</a:t>
+              <a:t>RF-DETR Nano</a:t>
             </a:r>
             <a:endParaRPr lang="en-US" sz="2700" dirty="0"/>
           </a:p>
@@ -4483,8 +4483,8 @@
         </p:nvSpPr>
         <p:spPr>
           <a:xfrm>
-            <a:off x="7699248" y="2112264"/>
-            <a:ext cx="3840480" cy="713232"/>
+            <a:off x="7699248" y="1975104"/>
+            <a:ext cx="3840480" cy="566928"/>
           </a:xfrm>
           <a:prstGeom prst="rect">
             <a:avLst/>
@@ -4510,7 +4510,7 @@
                 <a:ea typeface="Segoe UI" pitchFamily="34" charset="-122"/>
                 <a:cs typeface="Segoe UI" pitchFamily="34" charset="-120"/>
               </a:rPr>
-              <a:t>Руки, наличные, удостоверения, счётчики</a:t>
+              <a:t>люди и общие объекты</a:t>
             </a:r>
             <a:endParaRPr lang="en-US" sz="2200" dirty="0"/>
           </a:p>
@@ -4524,8 +4524,8 @@
         </p:nvSpPr>
         <p:spPr>
           <a:xfrm>
-            <a:off x="7699248" y="3127248"/>
-            <a:ext cx="3840480" cy="493776"/>
+            <a:off x="7699248" y="2889504"/>
+            <a:ext cx="3840480" cy="512064"/>
           </a:xfrm>
           <a:prstGeom prst="rect">
             <a:avLst/>
@@ -4551,7 +4551,7 @@
                 <a:ea typeface="Segoe UI" pitchFamily="34" charset="-122"/>
                 <a:cs typeface="Segoe UI" pitchFamily="34" charset="-120"/>
               </a:rPr>
-              <a:t>Трекинг</a:t>
+              <a:t>RT-DETRv2-r18</a:t>
             </a:r>
             <a:endParaRPr lang="en-US" sz="2700" dirty="0"/>
           </a:p>
@@ -4565,8 +4565,8 @@
         </p:nvSpPr>
         <p:spPr>
           <a:xfrm>
-            <a:off x="7699248" y="3685032"/>
-            <a:ext cx="3840480" cy="694944"/>
+            <a:off x="7699248" y="3456432"/>
+            <a:ext cx="3840480" cy="566928"/>
           </a:xfrm>
           <a:prstGeom prst="rect">
             <a:avLst/>
@@ -4592,7 +4592,7 @@
                 <a:ea typeface="Segoe UI" pitchFamily="34" charset="-122"/>
                 <a:cs typeface="Segoe UI" pitchFamily="34" charset="-120"/>
               </a:rPr>
-              <a:t>Тот же человек и предмет между кадрами</a:t>
+              <a:t>руки, банкноты, счётчик</a:t>
             </a:r>
             <a:endParaRPr lang="en-US" sz="2200" dirty="0"/>
           </a:p>
@@ -4606,7 +4606,7 @@
         </p:nvSpPr>
         <p:spPr>
           <a:xfrm>
-            <a:off x="7699248" y="4617720"/>
+            <a:off x="7699248" y="4370832"/>
             <a:ext cx="3977640" cy="512064"/>
           </a:xfrm>
           <a:prstGeom prst="rect">
@@ -4625,7 +4625,7 @@
               <a:buNone/>
             </a:pPr>
             <a:r>
-              <a:rPr lang="en-US" sz="2500" b="1" dirty="0">
+              <a:rPr lang="en-US" sz="2700" b="1" dirty="0">
                 <a:solidFill>
                   <a:srgbClr val="A31551"/>
                 </a:solidFill>
@@ -4633,9 +4633,9 @@
                 <a:ea typeface="Segoe UI" pitchFamily="34" charset="-122"/>
                 <a:cs typeface="Segoe UI" pitchFamily="34" charset="-120"/>
               </a:rPr>
-              <a:t>Последовательность</a:t>
-            </a:r>
-            <a:endParaRPr lang="en-US" sz="2500" dirty="0"/>
+              <a:t>Qwen3-VL-8B</a:t>
+            </a:r>
+            <a:endParaRPr lang="en-US" sz="2700" dirty="0"/>
           </a:p>
         </p:txBody>
       </p:sp>
@@ -4647,8 +4647,8 @@
         </p:nvSpPr>
         <p:spPr>
           <a:xfrm>
-            <a:off x="7699248" y="5138928"/>
-            <a:ext cx="3840480" cy="1207008"/>
+            <a:off x="7699248" y="4882896"/>
+            <a:ext cx="3840480" cy="1298448"/>
           </a:xfrm>
           <a:prstGeom prst="rect">
             <a:avLst/>
@@ -4674,7 +4674,7 @@
                 <a:ea typeface="Segoe UI" pitchFamily="34" charset="-122"/>
                 <a:cs typeface="Segoe UI" pitchFamily="34" charset="-120"/>
               </a:rPr>
-              <a:t>Qwen3-VL читает</a:t>
+              <a:t>последовательность</a:t>
             </a:r>
             <a:endParaRPr lang="en-US" sz="2200" dirty="0"/>
           </a:p>
@@ -4691,7 +4691,7 @@
                 <a:ea typeface="Segoe UI" pitchFamily="34" charset="-122"/>
                 <a:cs typeface="Segoe UI" pitchFamily="34" charset="-120"/>
               </a:rPr>
-              <a:t>последовательность.</a:t>
+              <a:t>и действия</a:t>
             </a:r>
             <a:endParaRPr lang="en-US" sz="2200" dirty="0"/>
           </a:p>
@@ -4708,7 +4708,7 @@
                 <a:ea typeface="Segoe UI" pitchFamily="34" charset="-122"/>
                 <a:cs typeface="Segoe UI" pitchFamily="34" charset="-120"/>
               </a:rPr>
-              <a:t>Код сверяет объекты</a:t>
+              <a:t>код сверяет объекты</a:t>
             </a:r>
             <a:endParaRPr lang="en-US" sz="2200" dirty="0"/>
           </a:p>
@@ -4725,7 +4725,7 @@
                 <a:ea typeface="Segoe UI" pitchFamily="34" charset="-122"/>
                 <a:cs typeface="Segoe UI" pitchFamily="34" charset="-120"/>
               </a:rPr>
-              <a:t>и время.</a:t>
+              <a:t>и время</a:t>
             </a:r>
             <a:endParaRPr lang="en-US" sz="2200" dirty="0"/>
           </a:p>
@@ -5550,7 +5550,7 @@
         <p:spPr>
           <a:xfrm>
             <a:off x="713232" y="6071616"/>
-            <a:ext cx="9601200" cy="566928"/>
+            <a:ext cx="9875520" cy="566928"/>
           </a:xfrm>
           <a:prstGeom prst="rect">
             <a:avLst/>
@@ -5576,7 +5576,7 @@
                 <a:ea typeface="Segoe UI" pitchFamily="34" charset="-122"/>
                 <a:cs typeface="Segoe UI" pitchFamily="34" charset="-120"/>
               </a:rPr>
-              <a:t>Источник и ограничения хранятся вместе с правилом.</a:t>
+              <a:t>Правило хранит источник, ограничения и кадры-доказательства.</a:t>
             </a:r>
             <a:endParaRPr lang="en-US" sz="2200" dirty="0"/>
           </a:p>
@@ -6340,7 +6340,7 @@
                 <a:ea typeface="Segoe UI" pitchFamily="34" charset="-122"/>
                 <a:cs typeface="Segoe UI" pitchFamily="34" charset="-120"/>
               </a:rPr>
-              <a:t>Проверим Lado</a:t>
+              <a:t>Каждая находка</a:t>
             </a:r>
             <a:endParaRPr lang="en-US" sz="5500" dirty="0"/>
           </a:p>
@@ -6357,7 +6357,7 @@
                 <a:ea typeface="Segoe UI" pitchFamily="34" charset="-122"/>
                 <a:cs typeface="Segoe UI" pitchFamily="34" charset="-120"/>
               </a:rPr>
-              <a:t>на ваших сценариях</a:t>
+              <a:t>с доказательством</a:t>
             </a:r>
             <a:endParaRPr lang="en-US" sz="5500" dirty="0"/>
           </a:p>
@@ -6372,7 +6372,7 @@
         <p:spPr>
           <a:xfrm>
             <a:off x="694944" y="3364992"/>
-            <a:ext cx="6583680" cy="1042416"/>
+            <a:ext cx="6766560" cy="1042416"/>
           </a:xfrm>
           <a:prstGeom prst="rect">
             <a:avLst/>
@@ -6398,7 +6398,7 @@
                 <a:ea typeface="Segoe UI" pitchFamily="34" charset="-122"/>
                 <a:cs typeface="Segoe UI" pitchFamily="34" charset="-120"/>
               </a:rPr>
-              <a:t>Начнём с одного процесса.</a:t>
+              <a:t>Таймкод, правило и кадры</a:t>
             </a:r>
             <a:endParaRPr lang="en-US" sz="2600" dirty="0"/>
           </a:p>
@@ -6415,7 +6415,7 @@
                 <a:ea typeface="Segoe UI" pitchFamily="34" charset="-122"/>
                 <a:cs typeface="Segoe UI" pitchFamily="34" charset="-120"/>
               </a:rPr>
-              <a:t>Сопоставим эпизоды с решениями специалистов.</a:t>
+              <a:t>в одном рабочем пространстве.</a:t>
             </a:r>
             <a:endParaRPr lang="en-US" sz="2600" dirty="0"/>
           </a:p>
@@ -6518,47 +6518,6 @@
               <a:t>Репозиторий ↗</a:t>
             </a:r>
             <a:endParaRPr lang="en-US" sz="2200" dirty="0"/>
-          </a:p>
-        </p:txBody>
-      </p:sp>
-      <p:sp>
-        <p:nvSpPr>
-          <p:cNvPr id="9" name="Repository access"/>
-          <p:cNvSpPr txBox="1"/>
-          <p:nvPr/>
-        </p:nvSpPr>
-        <p:spPr>
-          <a:xfrm>
-            <a:off x="694944" y="5833872"/>
-            <a:ext cx="6583680" cy="512064"/>
-          </a:xfrm>
-          <a:prstGeom prst="rect">
-            <a:avLst/>
-          </a:prstGeom>
-          <a:noFill/>
-          <a:ln/>
-        </p:spPr>
-        <p:txBody>
-          <a:bodyPr wrap="square" lIns="0" tIns="0" rIns="0" bIns="0" rtlCol="0" anchor="t">
-            <a:normAutofit/>
-          </a:bodyPr>
-          <a:lstStyle/>
-          <a:p>
-            <a:pPr algn="l" indent="0" marL="0">
-              <a:buNone/>
-            </a:pPr>
-            <a:r>
-              <a:rPr lang="en-US" sz="2000" dirty="0">
-                <a:solidFill>
-                  <a:srgbClr val="FFFFFF"/>
-                </a:solidFill>
-                <a:latin typeface="Segoe UI" pitchFamily="34" charset="0"/>
-                <a:ea typeface="Segoe UI" pitchFamily="34" charset="-122"/>
-                <a:cs typeface="Segoe UI" pitchFamily="34" charset="-120"/>
-              </a:rPr>
-              <a:t>Доступ к репозиторию — по приглашению.</a:t>
-            </a:r>
-            <a:endParaRPr lang="en-US" sz="2000" dirty="0"/>
           </a:p>
         </p:txBody>
       </p:sp>

</xml_diff>